<commit_message>
docs: slides motor rewrite and two-phase AI development
</commit_message>
<xml_diff>
--- a/docs/slides/defensa-tfm.pptx
+++ b/docs/slides/defensa-tfm.pptx
@@ -513,7 +513,7 @@
           <a:p>
             <a:r>
               <a:rPr lang="en-US" dirty="0"/>
-              <a:t>Nota: Preséntate en 20 segundos: ingeniero que invierte por hobby y quería decisiones con base cuantitativa, no corazonadas. El proyecto es real y personal: lo usas tú. Eso responde al "proyecto original que te ilusione" del TFM.</a:t>
+              <a:t/>
             </a:r>
             <a:endParaRPr lang="en-US" dirty="0"/>
           </a:p>
@@ -601,7 +601,7 @@
           <a:p>
             <a:r>
               <a:rPr lang="en-US" dirty="0"/>
-              <a:t>Nota: Ten abierta también la URL local por si falla la red en la defensa. Si la IA da 429 en directo, perfecto: enseñas el fallback amistoso (es una feature, no un fallo). No enseñes más de 4 pantallas.</a:t>
+              <a:t/>
             </a:r>
             <a:endParaRPr lang="en-US" dirty="0"/>
           </a:p>
@@ -689,7 +689,7 @@
           <a:p>
             <a:r>
               <a:rPr lang="en-US" dirty="0"/>
-              <a:t>Nota: Sé honesto con lo que NO hace (el disclaimer está en el README). Cada futuro enlaza con una decisión ya tomada: Swagger descartado a posta, ML desacoplado por hexagonal, Boot 4.x como riesgo aceptado documentado.</a:t>
+              <a:t/>
             </a:r>
             <a:endParaRPr lang="en-US" dirty="0"/>
           </a:p>
@@ -777,7 +777,7 @@
           <a:p>
             <a:r>
               <a:rPr lang="en-US" dirty="0"/>
-              <a:t>Nota: Cierra con las 5 piezas del TFM marcadas y pide preguntas. Ten a mano: repo, deploy, PDF de slides y formulario. Termina con qué te llevas del máster en una frase.</a:t>
+              <a:t/>
             </a:r>
             <a:endParaRPr lang="en-US" dirty="0"/>
           </a:p>
@@ -865,7 +865,7 @@
           <a:p>
             <a:r>
               <a:rPr lang="en-US" dirty="0"/>
-              <a:t>Nota: Cuenta tu rutina real: tarde de domingo en Finviz, 40 candidatas, pestaña por pestaña. La app automatiza justo ese primer corte que hacías a mano — lo de invertir viene mucho después, tras el análisis fundamental de históricos y beneficios de las elegidas.</a:t>
+              <a:t/>
             </a:r>
             <a:endParaRPr lang="en-US" dirty="0"/>
           </a:p>
@@ -953,7 +953,7 @@
           <a:p>
             <a:r>
               <a:rPr lang="en-US" dirty="0"/>
-              <a:t>Nota: Esta es LA frase del TFM: determinista para decidir, IA para interpretar. Si el tribunal se queda con una idea, que sea esta. Anticípate: "¿y si falla la IA?" → "nada se rompe, lo veréis en la demo".</a:t>
+              <a:t/>
             </a:r>
             <a:endParaRPr lang="en-US" dirty="0"/>
           </a:p>
@@ -1041,7 +1041,7 @@
           <a:p>
             <a:r>
               <a:rPr lang="en-US" dirty="0"/>
-              <a:t>Nota: Recorre el flujo señalando que cada paso es un caso de uso independiente (ManageAnalyzeTicker, SuggestTickers, EvaluateStrategy…). Si preguntan "¿dónde está la lógica?", respuesta: en el dominio, nunca en los controladores.</a:t>
+              <a:t/>
             </a:r>
             <a:endParaRPr lang="en-US" dirty="0"/>
           </a:p>
@@ -1129,7 +1129,7 @@
           <a:p>
             <a:r>
               <a:rPr lang="en-US" dirty="0"/>
-              <a:t>Nota: Explica de fuera a dentro: Thymeleaf/MVC solo presenta; Application orquesta casos de uso; Domain (Rule, Strategy, RuleEvaluator) no importa nada de Spring — verificado; Infrastructure adapta JPA, APIs e IA. Cambiar de proveedor = tocar un adapter.</a:t>
+              <a:t/>
             </a:r>
             <a:endParaRPr lang="en-US" dirty="0"/>
           </a:p>
@@ -1217,7 +1217,7 @@
           <a:p>
             <a:r>
               <a:rPr lang="en-US" dirty="0"/>
-              <a:t>Nota: Enseña un ejemplo vivo si puedes: estrategia PRICE &gt; SMA50 con threshold 70. El scoring ponderado fue el bloque central del cierre (4 PRs). El catálogo es el "guardián" contra combinaciones imposibles.</a:t>
+              <a:t/>
             </a:r>
             <a:endParaRPr lang="en-US" dirty="0"/>
           </a:p>
@@ -1305,7 +1305,7 @@
           <a:p>
             <a:r>
               <a:rPr lang="en-US" dirty="0"/>
-              <a:t>Nota: Este slide blinda la pregunta "¿y la IA no se equivoca?". Respuesta: puede fallar el texto, nunca los números. Menciona el caso real de tus logs: los 5 modelos en 429 y la app siguió funcionando con fallback.</a:t>
+              <a:t/>
             </a:r>
             <a:endParaRPr lang="en-US" dirty="0"/>
           </a:p>
@@ -1393,7 +1393,7 @@
           <a:p>
             <a:r>
               <a:rPr lang="en-US" dirty="0"/>
-              <a:t>Nota: Se probó Railway primero, pero la latencia con la base de datos penalizaba cada consulta; el VPS dio control total y, sobre todo, aprendizaje de verdad en seguridad (fail2ban, backups, red, certificados). Los números (1165, 63→0) son tu prueba de "buen proyecto de software", no un fichero de 10.000 líneas.</a:t>
+              <a:t/>
             </a:r>
             <a:endParaRPr lang="en-US" dirty="0"/>
           </a:p>
@@ -1481,7 +1481,7 @@
           <a:p>
             <a:r>
               <a:rPr lang="en-US" dirty="0"/>
-              <a:t>Nota: Aquí demuestras lo que el máster evalúa: no "código escupido por IA", sino proceso disciplinado. Cita artefactos: AGENTS.md §3, docs/prompts/ (9 patrones), ADRs. El tribunal valora originalidad + disfrute: di qué parte disfrutaste más.</a:t>
+              <a:t/>
             </a:r>
             <a:endParaRPr lang="en-US" dirty="0"/>
           </a:p>

</xml_diff>